<commit_message>
Fix Ch1 Q4 answer to A, B, C; note Omega(n) is a loose lower bound
Co-Authored-By: Claude Opus 5 (1M context) <noreply@anthropic.com>
</commit_message>
<xml_diff>
--- a/courseware/202609_DSA_MOOC_Quiz_CH01-02.pptx
+++ b/courseware/202609_DSA_MOOC_Quiz_CH01-02.pptx
@@ -1501,11 +1501,12 @@
           <a:p>
             <a:r>
               <a:rPr lang="en-US" dirty="0"/>
-              <a:t>答案：A、B
-外层为 i 时内层执行 n−1−i 次，
-总次数 = n(n−1)/2 = Θ(n2)。
-因此上界 O(n2) 成立，下界 Ω(n) 也成立；O(n) 不成立。
-Θ(n2) 是最精确的界（MOOC 标准答案为 A、B）。</a:t>
+              <a:t>答案：A、B、C
+内层执行 n−1−i 次，总次数 = n(n−1)/2 = Θ(n2)。
+Θ 同时给出上界和下界：O(n2) 与 Ω(n2) 都成立。
+A ✓ Ω(n) 成立，但只是松下界（紧下界是 Ω(n2)）。
+B ✓ O(n2) 是紧上界；C ✓ Θ(n2) 最精确。
+D ✗ n2 增长快于 n，O(n) 不成立。</a:t>
             </a:r>
             <a:endParaRPr lang="en-US" dirty="0"/>
           </a:p>
@@ -13512,7 +13513,31 @@
       </p:sp>
       <p:sp>
         <p:nvSpPr>
-          <p:cNvPr id="19" name="ANS_panel"/>
+          <p:cNvPr id="19" name="ANS_hl2"/>
+          <p:cNvSpPr/>
+          <p:nvPr/>
+        </p:nvSpPr>
+        <p:spPr>
+          <a:xfrm>
+            <a:off x="3771900" y="4344416"/>
+            <a:ext cx="1474470" cy="822960"/>
+          </a:xfrm>
+          <a:prstGeom prst="roundRect">
+            <a:avLst>
+              <a:gd name="adj" fmla="val 11111"/>
+            </a:avLst>
+          </a:prstGeom>
+          <a:ln w="38100">
+            <a:solidFill>
+              <a:srgbClr val="2E9E6B"/>
+            </a:solidFill>
+            <a:prstDash val="solid"/>
+          </a:ln>
+        </p:spPr>
+      </p:sp>
+      <p:sp>
+        <p:nvSpPr>
+          <p:cNvPr id="20" name="ANS_panel"/>
           <p:cNvSpPr/>
           <p:nvPr/>
         </p:nvSpPr>
@@ -13539,7 +13564,7 @@
       </p:sp>
       <p:sp>
         <p:nvSpPr>
-          <p:cNvPr id="20" name="ANS_label"/>
+          <p:cNvPr id="21" name="ANS_label"/>
           <p:cNvSpPr txBox="1"/>
           <p:nvPr/>
         </p:nvSpPr>
@@ -13578,7 +13603,7 @@
       </p:sp>
       <p:sp>
         <p:nvSpPr>
-          <p:cNvPr id="21" name="ANS_value"/>
+          <p:cNvPr id="22" name="ANS_value"/>
           <p:cNvSpPr txBox="1"/>
           <p:nvPr/>
         </p:nvSpPr>
@@ -13609,7 +13634,7 @@
                 <a:ea typeface="Arial" pitchFamily="34" charset="-122"/>
                 <a:cs typeface="Arial" pitchFamily="34" charset="-120"/>
               </a:rPr>
-              <a:t>A、B</a:t>
+              <a:t>A、B、C</a:t>
             </a:r>
             <a:endParaRPr lang="en-US" sz="4400" dirty="0"/>
           </a:p>
@@ -13617,7 +13642,7 @@
       </p:sp>
       <p:sp>
         <p:nvSpPr>
-          <p:cNvPr id="22" name="ANS_label2"/>
+          <p:cNvPr id="23" name="ANS_label2"/>
           <p:cNvSpPr txBox="1"/>
           <p:nvPr/>
         </p:nvSpPr>
@@ -13656,7 +13681,7 @@
       </p:sp>
       <p:sp>
         <p:nvSpPr>
-          <p:cNvPr id="23" name="ANS_dot0"/>
+          <p:cNvPr id="24" name="ANS_dot0"/>
           <p:cNvSpPr/>
           <p:nvPr/>
         </p:nvSpPr>
@@ -13676,7 +13701,7 @@
       </p:sp>
       <p:sp>
         <p:nvSpPr>
-          <p:cNvPr id="24" name="ANS_exp0"/>
+          <p:cNvPr id="25" name="ANS_exp0"/>
           <p:cNvSpPr txBox="1"/>
           <p:nvPr/>
         </p:nvSpPr>
@@ -13707,7 +13732,35 @@
                 <a:ea typeface="Microsoft YaHei" pitchFamily="34" charset="-122"/>
                 <a:cs typeface="Microsoft YaHei" pitchFamily="34" charset="-120"/>
               </a:rPr>
-              <a:t>外层为 i 时内层执行 n−1−i 次，</a:t>
+              <a:t>内层执行 n−1−i 次，总次数 = n(n−1)/2 = Θ(n</a:t>
+            </a:r>
+            <a:pPr indent="0" marL="0">
+              <a:buNone/>
+            </a:pPr>
+            <a:r>
+              <a:rPr lang="en-US" sz="1700" baseline="30000" dirty="0">
+                <a:solidFill>
+                  <a:srgbClr val="2B2B2B"/>
+                </a:solidFill>
+                <a:latin typeface="Microsoft YaHei" pitchFamily="34" charset="0"/>
+                <a:ea typeface="Microsoft YaHei" pitchFamily="34" charset="-122"/>
+                <a:cs typeface="Microsoft YaHei" pitchFamily="34" charset="-120"/>
+              </a:rPr>
+              <a:t>2</a:t>
+            </a:r>
+            <a:pPr indent="0" marL="0">
+              <a:buNone/>
+            </a:pPr>
+            <a:r>
+              <a:rPr lang="en-US" sz="1700" dirty="0">
+                <a:solidFill>
+                  <a:srgbClr val="2B2B2B"/>
+                </a:solidFill>
+                <a:latin typeface="Microsoft YaHei" pitchFamily="34" charset="0"/>
+                <a:ea typeface="Microsoft YaHei" pitchFamily="34" charset="-122"/>
+                <a:cs typeface="Microsoft YaHei" pitchFamily="34" charset="-120"/>
+              </a:rPr>
+              <a:t>)。</a:t>
             </a:r>
             <a:endParaRPr lang="en-US" sz="1700" dirty="0"/>
           </a:p>
@@ -13715,7 +13768,7 @@
       </p:sp>
       <p:sp>
         <p:nvSpPr>
-          <p:cNvPr id="25" name="ANS_dot1"/>
+          <p:cNvPr id="26" name="ANS_dot1"/>
           <p:cNvSpPr/>
           <p:nvPr/>
         </p:nvSpPr>
@@ -13735,14 +13788,14 @@
       </p:sp>
       <p:sp>
         <p:nvSpPr>
-          <p:cNvPr id="26" name="ANS_exp1"/>
+          <p:cNvPr id="27" name="ANS_exp1"/>
           <p:cNvSpPr txBox="1"/>
           <p:nvPr/>
         </p:nvSpPr>
         <p:spPr>
           <a:xfrm>
             <a:off x="7818120" y="3395980"/>
-            <a:ext cx="3520440" cy="326390"/>
+            <a:ext cx="3520440" cy="607060"/>
           </a:xfrm>
           <a:prstGeom prst="rect">
             <a:avLst/>
@@ -13758,6 +13811,20 @@
               <a:buNone/>
             </a:pPr>
             <a:r>
+              <a:rPr lang="en-US" sz="1700" b="1" dirty="0">
+                <a:solidFill>
+                  <a:srgbClr val="2B2B2B"/>
+                </a:solidFill>
+                <a:latin typeface="Microsoft YaHei" pitchFamily="34" charset="0"/>
+                <a:ea typeface="Microsoft YaHei" pitchFamily="34" charset="-122"/>
+                <a:cs typeface="Microsoft YaHei" pitchFamily="34" charset="-120"/>
+              </a:rPr>
+              <a:t>Θ 同时给出上界和下界</a:t>
+            </a:r>
+            <a:pPr indent="0" marL="0">
+              <a:buNone/>
+            </a:pPr>
+            <a:r>
               <a:rPr lang="en-US" sz="1700" dirty="0">
                 <a:solidFill>
                   <a:srgbClr val="2B2B2B"/>
@@ -13766,7 +13833,7 @@
                 <a:ea typeface="Microsoft YaHei" pitchFamily="34" charset="-122"/>
                 <a:cs typeface="Microsoft YaHei" pitchFamily="34" charset="-120"/>
               </a:rPr>
-              <a:t>总次数 = n(n−1)/2 = Θ(n</a:t>
+              <a:t>：O(n</a:t>
             </a:r>
             <a:pPr indent="0" marL="0">
               <a:buNone/>
@@ -13794,7 +13861,35 @@
                 <a:ea typeface="Microsoft YaHei" pitchFamily="34" charset="-122"/>
                 <a:cs typeface="Microsoft YaHei" pitchFamily="34" charset="-120"/>
               </a:rPr>
-              <a:t>)。</a:t>
+              <a:t>) 与 Ω(n</a:t>
+            </a:r>
+            <a:pPr indent="0" marL="0">
+              <a:buNone/>
+            </a:pPr>
+            <a:r>
+              <a:rPr lang="en-US" sz="1700" baseline="30000" dirty="0">
+                <a:solidFill>
+                  <a:srgbClr val="2B2B2B"/>
+                </a:solidFill>
+                <a:latin typeface="Microsoft YaHei" pitchFamily="34" charset="0"/>
+                <a:ea typeface="Microsoft YaHei" pitchFamily="34" charset="-122"/>
+                <a:cs typeface="Microsoft YaHei" pitchFamily="34" charset="-120"/>
+              </a:rPr>
+              <a:t>2</a:t>
+            </a:r>
+            <a:pPr indent="0" marL="0">
+              <a:buNone/>
+            </a:pPr>
+            <a:r>
+              <a:rPr lang="en-US" sz="1700" dirty="0">
+                <a:solidFill>
+                  <a:srgbClr val="2B2B2B"/>
+                </a:solidFill>
+                <a:latin typeface="Microsoft YaHei" pitchFamily="34" charset="0"/>
+                <a:ea typeface="Microsoft YaHei" pitchFamily="34" charset="-122"/>
+                <a:cs typeface="Microsoft YaHei" pitchFamily="34" charset="-120"/>
+              </a:rPr>
+              <a:t>) 都成立。</a:t>
             </a:r>
             <a:endParaRPr lang="en-US" sz="1700" dirty="0"/>
           </a:p>
@@ -13802,13 +13897,13 @@
       </p:sp>
       <p:sp>
         <p:nvSpPr>
-          <p:cNvPr id="27" name="ANS_dot2"/>
+          <p:cNvPr id="28" name="ANS_dot2"/>
           <p:cNvSpPr/>
           <p:nvPr/>
         </p:nvSpPr>
         <p:spPr>
           <a:xfrm>
-            <a:off x="7616952" y="3978402"/>
+            <a:off x="7616952" y="4259072"/>
             <a:ext cx="91440" cy="91440"/>
           </a:xfrm>
           <a:prstGeom prst="ellipse">
@@ -13822,13 +13917,13 @@
       </p:sp>
       <p:sp>
         <p:nvSpPr>
-          <p:cNvPr id="28" name="ANS_exp2"/>
+          <p:cNvPr id="29" name="ANS_exp2"/>
           <p:cNvSpPr txBox="1"/>
           <p:nvPr/>
         </p:nvSpPr>
         <p:spPr>
           <a:xfrm>
-            <a:off x="7818120" y="3859530"/>
+            <a:off x="7818120" y="4140200"/>
             <a:ext cx="3520440" cy="607060"/>
           </a:xfrm>
           <a:prstGeom prst="rect">
@@ -13845,6 +13940,20 @@
               <a:buNone/>
             </a:pPr>
             <a:r>
+              <a:rPr lang="en-US" sz="1700" b="1" dirty="0">
+                <a:solidFill>
+                  <a:srgbClr val="2B2B2B"/>
+                </a:solidFill>
+                <a:latin typeface="Microsoft YaHei" pitchFamily="34" charset="0"/>
+                <a:ea typeface="Microsoft YaHei" pitchFamily="34" charset="-122"/>
+                <a:cs typeface="Microsoft YaHei" pitchFamily="34" charset="-120"/>
+              </a:rPr>
+              <a:t>A ✓</a:t>
+            </a:r>
+            <a:pPr indent="0" marL="0">
+              <a:buNone/>
+            </a:pPr>
+            <a:r>
               <a:rPr lang="en-US" sz="1700" dirty="0">
                 <a:solidFill>
                   <a:srgbClr val="2B2B2B"/>
@@ -13853,7 +13962,35 @@
                 <a:ea typeface="Microsoft YaHei" pitchFamily="34" charset="-122"/>
                 <a:cs typeface="Microsoft YaHei" pitchFamily="34" charset="-120"/>
               </a:rPr>
-              <a:t>因此上界 O(n</a:t>
+              <a:t> Ω(n) 成立，但只是</a:t>
+            </a:r>
+            <a:pPr indent="0" marL="0">
+              <a:buNone/>
+            </a:pPr>
+            <a:r>
+              <a:rPr lang="en-US" sz="1700" b="1" dirty="0">
+                <a:solidFill>
+                  <a:srgbClr val="2B2B2B"/>
+                </a:solidFill>
+                <a:latin typeface="Microsoft YaHei" pitchFamily="34" charset="0"/>
+                <a:ea typeface="Microsoft YaHei" pitchFamily="34" charset="-122"/>
+                <a:cs typeface="Microsoft YaHei" pitchFamily="34" charset="-120"/>
+              </a:rPr>
+              <a:t>松下界</a:t>
+            </a:r>
+            <a:pPr indent="0" marL="0">
+              <a:buNone/>
+            </a:pPr>
+            <a:r>
+              <a:rPr lang="en-US" sz="1700" dirty="0">
+                <a:solidFill>
+                  <a:srgbClr val="2B2B2B"/>
+                </a:solidFill>
+                <a:latin typeface="Microsoft YaHei" pitchFamily="34" charset="0"/>
+                <a:ea typeface="Microsoft YaHei" pitchFamily="34" charset="-122"/>
+                <a:cs typeface="Microsoft YaHei" pitchFamily="34" charset="-120"/>
+              </a:rPr>
+              <a:t>（紧下界是 Ω(n</a:t>
             </a:r>
             <a:pPr indent="0" marL="0">
               <a:buNone/>
@@ -13881,7 +14018,7 @@
                 <a:ea typeface="Microsoft YaHei" pitchFamily="34" charset="-122"/>
                 <a:cs typeface="Microsoft YaHei" pitchFamily="34" charset="-120"/>
               </a:rPr>
-              <a:t>) 成立，下界 Ω(n) 也成立；O(n) 不成立。</a:t>
+              <a:t>)）。</a:t>
             </a:r>
             <a:endParaRPr lang="en-US" sz="1700" dirty="0"/>
           </a:p>
@@ -13889,13 +14026,13 @@
       </p:sp>
       <p:sp>
         <p:nvSpPr>
-          <p:cNvPr id="29" name="ANS_dot3"/>
+          <p:cNvPr id="30" name="ANS_dot3"/>
           <p:cNvSpPr/>
           <p:nvPr/>
         </p:nvSpPr>
         <p:spPr>
           <a:xfrm>
-            <a:off x="7616952" y="4722622"/>
+            <a:off x="7616952" y="5003292"/>
             <a:ext cx="91440" cy="91440"/>
           </a:xfrm>
           <a:prstGeom prst="ellipse">
@@ -13909,13 +14046,13 @@
       </p:sp>
       <p:sp>
         <p:nvSpPr>
-          <p:cNvPr id="30" name="ANS_exp3"/>
+          <p:cNvPr id="31" name="ANS_exp3"/>
           <p:cNvSpPr txBox="1"/>
           <p:nvPr/>
         </p:nvSpPr>
         <p:spPr>
           <a:xfrm>
-            <a:off x="7818120" y="4603750"/>
+            <a:off x="7818120" y="4884420"/>
             <a:ext cx="3520440" cy="607060"/>
           </a:xfrm>
           <a:prstGeom prst="rect">
@@ -13932,6 +14069,20 @@
               <a:buNone/>
             </a:pPr>
             <a:r>
+              <a:rPr lang="en-US" sz="1700" b="1" dirty="0">
+                <a:solidFill>
+                  <a:srgbClr val="2B2B2B"/>
+                </a:solidFill>
+                <a:latin typeface="Microsoft YaHei" pitchFamily="34" charset="0"/>
+                <a:ea typeface="Microsoft YaHei" pitchFamily="34" charset="-122"/>
+                <a:cs typeface="Microsoft YaHei" pitchFamily="34" charset="-120"/>
+              </a:rPr>
+              <a:t>B ✓</a:t>
+            </a:r>
+            <a:pPr indent="0" marL="0">
+              <a:buNone/>
+            </a:pPr>
+            <a:r>
               <a:rPr lang="en-US" sz="1700" dirty="0">
                 <a:solidFill>
                   <a:srgbClr val="2B2B2B"/>
@@ -13940,7 +14091,7 @@
                 <a:ea typeface="Microsoft YaHei" pitchFamily="34" charset="-122"/>
                 <a:cs typeface="Microsoft YaHei" pitchFamily="34" charset="-120"/>
               </a:rPr>
-              <a:t>Θ(n</a:t>
+              <a:t> O(n</a:t>
             </a:r>
             <a:pPr indent="0" marL="0">
               <a:buNone/>
@@ -13968,7 +14119,164 @@
                 <a:ea typeface="Microsoft YaHei" pitchFamily="34" charset="-122"/>
                 <a:cs typeface="Microsoft YaHei" pitchFamily="34" charset="-120"/>
               </a:rPr>
-              <a:t>) 是最精确的界（MOOC 标准答案为 A、B）。</a:t>
+              <a:t>) 是紧上界；</a:t>
+            </a:r>
+            <a:pPr indent="0" marL="0">
+              <a:buNone/>
+            </a:pPr>
+            <a:r>
+              <a:rPr lang="en-US" sz="1700" b="1" dirty="0">
+                <a:solidFill>
+                  <a:srgbClr val="2B2B2B"/>
+                </a:solidFill>
+                <a:latin typeface="Microsoft YaHei" pitchFamily="34" charset="0"/>
+                <a:ea typeface="Microsoft YaHei" pitchFamily="34" charset="-122"/>
+                <a:cs typeface="Microsoft YaHei" pitchFamily="34" charset="-120"/>
+              </a:rPr>
+              <a:t>C ✓</a:t>
+            </a:r>
+            <a:pPr indent="0" marL="0">
+              <a:buNone/>
+            </a:pPr>
+            <a:r>
+              <a:rPr lang="en-US" sz="1700" dirty="0">
+                <a:solidFill>
+                  <a:srgbClr val="2B2B2B"/>
+                </a:solidFill>
+                <a:latin typeface="Microsoft YaHei" pitchFamily="34" charset="0"/>
+                <a:ea typeface="Microsoft YaHei" pitchFamily="34" charset="-122"/>
+                <a:cs typeface="Microsoft YaHei" pitchFamily="34" charset="-120"/>
+              </a:rPr>
+              <a:t> Θ(n</a:t>
+            </a:r>
+            <a:pPr indent="0" marL="0">
+              <a:buNone/>
+            </a:pPr>
+            <a:r>
+              <a:rPr lang="en-US" sz="1700" baseline="30000" dirty="0">
+                <a:solidFill>
+                  <a:srgbClr val="2B2B2B"/>
+                </a:solidFill>
+                <a:latin typeface="Microsoft YaHei" pitchFamily="34" charset="0"/>
+                <a:ea typeface="Microsoft YaHei" pitchFamily="34" charset="-122"/>
+                <a:cs typeface="Microsoft YaHei" pitchFamily="34" charset="-120"/>
+              </a:rPr>
+              <a:t>2</a:t>
+            </a:r>
+            <a:pPr indent="0" marL="0">
+              <a:buNone/>
+            </a:pPr>
+            <a:r>
+              <a:rPr lang="en-US" sz="1700" dirty="0">
+                <a:solidFill>
+                  <a:srgbClr val="2B2B2B"/>
+                </a:solidFill>
+                <a:latin typeface="Microsoft YaHei" pitchFamily="34" charset="0"/>
+                <a:ea typeface="Microsoft YaHei" pitchFamily="34" charset="-122"/>
+                <a:cs typeface="Microsoft YaHei" pitchFamily="34" charset="-120"/>
+              </a:rPr>
+              <a:t>) 最精确。</a:t>
+            </a:r>
+            <a:endParaRPr lang="en-US" sz="1700" dirty="0"/>
+          </a:p>
+        </p:txBody>
+      </p:sp>
+      <p:sp>
+        <p:nvSpPr>
+          <p:cNvPr id="32" name="ANS_dot4"/>
+          <p:cNvSpPr/>
+          <p:nvPr/>
+        </p:nvSpPr>
+        <p:spPr>
+          <a:xfrm>
+            <a:off x="7616952" y="5747512"/>
+            <a:ext cx="91440" cy="91440"/>
+          </a:xfrm>
+          <a:prstGeom prst="ellipse">
+            <a:avLst/>
+          </a:prstGeom>
+          <a:solidFill>
+            <a:srgbClr val="F2B134"/>
+          </a:solidFill>
+          <a:ln/>
+        </p:spPr>
+      </p:sp>
+      <p:sp>
+        <p:nvSpPr>
+          <p:cNvPr id="33" name="ANS_exp4"/>
+          <p:cNvSpPr txBox="1"/>
+          <p:nvPr/>
+        </p:nvSpPr>
+        <p:spPr>
+          <a:xfrm>
+            <a:off x="7818120" y="5628640"/>
+            <a:ext cx="3520440" cy="607060"/>
+          </a:xfrm>
+          <a:prstGeom prst="rect">
+            <a:avLst/>
+          </a:prstGeom>
+          <a:noFill/>
+          <a:ln/>
+        </p:spPr>
+        <p:txBody>
+          <a:bodyPr wrap="square" lIns="0" tIns="0" rIns="0" bIns="0" rtlCol="0" anchor="t"/>
+          <a:lstStyle/>
+          <a:p>
+            <a:pPr indent="0" marL="0">
+              <a:buNone/>
+            </a:pPr>
+            <a:r>
+              <a:rPr lang="en-US" sz="1700" b="1" dirty="0">
+                <a:solidFill>
+                  <a:srgbClr val="2B2B2B"/>
+                </a:solidFill>
+                <a:latin typeface="Microsoft YaHei" pitchFamily="34" charset="0"/>
+                <a:ea typeface="Microsoft YaHei" pitchFamily="34" charset="-122"/>
+                <a:cs typeface="Microsoft YaHei" pitchFamily="34" charset="-120"/>
+              </a:rPr>
+              <a:t>D ✗</a:t>
+            </a:r>
+            <a:pPr indent="0" marL="0">
+              <a:buNone/>
+            </a:pPr>
+            <a:r>
+              <a:rPr lang="en-US" sz="1700" dirty="0">
+                <a:solidFill>
+                  <a:srgbClr val="2B2B2B"/>
+                </a:solidFill>
+                <a:latin typeface="Microsoft YaHei" pitchFamily="34" charset="0"/>
+                <a:ea typeface="Microsoft YaHei" pitchFamily="34" charset="-122"/>
+                <a:cs typeface="Microsoft YaHei" pitchFamily="34" charset="-120"/>
+              </a:rPr>
+              <a:t> n</a:t>
+            </a:r>
+            <a:pPr indent="0" marL="0">
+              <a:buNone/>
+            </a:pPr>
+            <a:r>
+              <a:rPr lang="en-US" sz="1700" baseline="30000" dirty="0">
+                <a:solidFill>
+                  <a:srgbClr val="2B2B2B"/>
+                </a:solidFill>
+                <a:latin typeface="Microsoft YaHei" pitchFamily="34" charset="0"/>
+                <a:ea typeface="Microsoft YaHei" pitchFamily="34" charset="-122"/>
+                <a:cs typeface="Microsoft YaHei" pitchFamily="34" charset="-120"/>
+              </a:rPr>
+              <a:t>2</a:t>
+            </a:r>
+            <a:pPr indent="0" marL="0">
+              <a:buNone/>
+            </a:pPr>
+            <a:r>
+              <a:rPr lang="en-US" sz="1700" dirty="0">
+                <a:solidFill>
+                  <a:srgbClr val="2B2B2B"/>
+                </a:solidFill>
+                <a:latin typeface="Microsoft YaHei" pitchFamily="34" charset="0"/>
+                <a:ea typeface="Microsoft YaHei" pitchFamily="34" charset="-122"/>
+                <a:cs typeface="Microsoft YaHei" pitchFamily="34" charset="-120"/>
+              </a:rPr>
+              <a:t> 增长快于 n，O(n) 不成立。</a:t>
             </a:r>
             <a:endParaRPr lang="en-US" sz="1700" dirty="0"/>
           </a:p>
@@ -14483,6 +14791,111 @@
                                         <p:cTn id="46" dur="400"/>
                                         <p:tgtEl>
                                           <p:spTgt spid="30"/>
+                                        </p:tgtEl>
+                                      </p:cBhvr>
+                                    </p:animEffect>
+                                  </p:childTnLst>
+                                </p:cTn>
+                              </p:par>
+                              <p:par>
+                                <p:cTn id="47" presetID="10" presetClass="entr" presetSubtype="0" fill="hold" grpId="0" nodeType="withEffect">
+                                  <p:stCondLst>
+                                    <p:cond delay="0"/>
+                                  </p:stCondLst>
+                                  <p:childTnLst>
+                                    <p:set>
+                                      <p:cBhvr>
+                                        <p:cTn id="48" dur="1" fill="hold">
+                                          <p:stCondLst>
+                                            <p:cond delay="0"/>
+                                          </p:stCondLst>
+                                        </p:cTn>
+                                        <p:tgtEl>
+                                          <p:spTgt spid="31"/>
+                                        </p:tgtEl>
+                                        <p:attrNameLst>
+                                          <p:attrName>style.visibility</p:attrName>
+                                        </p:attrNameLst>
+                                      </p:cBhvr>
+                                      <p:to>
+                                        <p:strVal val="visible"/>
+                                      </p:to>
+                                    </p:set>
+                                    <p:animEffect transition="in" filter="fade">
+                                      <p:cBhvr>
+                                        <p:cTn id="49" dur="400"/>
+                                        <p:tgtEl>
+                                          <p:spTgt spid="31"/>
+                                        </p:tgtEl>
+                                      </p:cBhvr>
+                                    </p:animEffect>
+                                  </p:childTnLst>
+                                </p:cTn>
+                              </p:par>
+                              <p:par>
+                                <p:cTn id="50" presetID="10" presetClass="entr" presetSubtype="0" fill="hold" grpId="0" nodeType="withEffect">
+                                  <p:stCondLst>
+                                    <p:cond delay="0"/>
+                                  </p:stCondLst>
+                                  <p:childTnLst>
+                                    <p:set>
+                                      <p:cBhvr>
+                                        <p:cTn id="51" dur="1" fill="hold">
+                                          <p:stCondLst>
+                                            <p:cond delay="0"/>
+                                          </p:stCondLst>
+                                        </p:cTn>
+                                        <p:tgtEl>
+                                          <p:spTgt spid="32"/>
+                                        </p:tgtEl>
+                                        <p:attrNameLst>
+                                          <p:attrName>style.visibility</p:attrName>
+                                        </p:attrNameLst>
+                                      </p:cBhvr>
+                                      <p:to>
+                                        <p:strVal val="visible"/>
+                                      </p:to>
+                                    </p:set>
+                                    <p:animEffect transition="in" filter="fade">
+                                      <p:cBhvr>
+                                        <p:cTn id="52" dur="400"/>
+                                        <p:tgtEl>
+                                          <p:spTgt spid="32"/>
+                                        </p:tgtEl>
+                                      </p:cBhvr>
+                                    </p:animEffect>
+                                  </p:childTnLst>
+                                </p:cTn>
+                              </p:par>
+                              <p:par>
+                                <p:cTn id="53" presetID="10" presetClass="entr" presetSubtype="0" fill="hold" grpId="0" nodeType="withEffect">
+                                  <p:stCondLst>
+                                    <p:cond delay="0"/>
+                                  </p:stCondLst>
+                                  <p:childTnLst>
+                                    <p:set>
+                                      <p:cBhvr>
+                                        <p:cTn id="54" dur="1" fill="hold">
+                                          <p:stCondLst>
+                                            <p:cond delay="0"/>
+                                          </p:stCondLst>
+                                        </p:cTn>
+                                        <p:tgtEl>
+                                          <p:spTgt spid="33"/>
+                                        </p:tgtEl>
+                                        <p:attrNameLst>
+                                          <p:attrName>style.visibility</p:attrName>
+                                        </p:attrNameLst>
+                                      </p:cBhvr>
+                                      <p:to>
+                                        <p:strVal val="visible"/>
+                                      </p:to>
+                                    </p:set>
+                                    <p:animEffect transition="in" filter="fade">
+                                      <p:cBhvr>
+                                        <p:cTn id="55" dur="400"/>
+                                        <p:tgtEl>
+                                          <p:spTgt spid="33"/>
                                         </p:tgtEl>
                                       </p:cBhvr>
                                     </p:animEffect>
@@ -14531,6 +14944,9 @@
       <p:bldP spid="28" grpId="0" animBg="1"/>
       <p:bldP spid="29" grpId="0" animBg="1"/>
       <p:bldP spid="30" grpId="0" animBg="1"/>
+      <p:bldP spid="31" grpId="0" animBg="1"/>
+      <p:bldP spid="32" grpId="0" animBg="1"/>
+      <p:bldP spid="33" grpId="0" animBg="1"/>
     </p:bldLst>
   </p:timing>
 </p:sld>

</xml_diff>

<commit_message>
Fix PowerPoint repair prompt: give notes master its own theme
pptxgenjs points the notes master and the slide master at the same
ppt/theme/theme1.xml. Schema validation and LibreOffice accept it, but
PowerPoint for Mac repairs the file on every open. This is the same root
cause as dsa-modernization T-077 (e30646c), fixed the same way: write a
separate theme2.xml for the notes master. Packages are also written with
[Content_Types].xml first and no directory entries, like the
PowerPoint-verified packages there.

- pptx_builder/lib.js: apply the fix in save(); add 'node lib.js check'
  and 'node lib.js fix in.pptx out.pptx'
- Regenerate the Ch3 deck; patch the MOOC quiz deck (same defect)

Co-Authored-By: Claude Opus 5 (1M context) <noreply@anthropic.com>
</commit_message>
<xml_diff>
--- a/courseware/202609_DSA_MOOC_Quiz_CH01-02.pptx
+++ b/courseware/202609_DSA_MOOC_Quiz_CH01-02.pptx
@@ -20397,4 +20397,299 @@
     </a:ext>
   </a:extLst>
 </a:theme>
+</file>
+
+<file path=ppt/theme/theme2.xml><?xml version="1.0" encoding="utf-8"?>
+<a:theme xmlns:a="http://schemas.openxmlformats.org/drawingml/2006/main" name="Office Theme">
+  <a:themeElements>
+    <a:clrScheme name="Office">
+      <a:dk1>
+        <a:sysClr val="windowText" lastClr="000000"/>
+      </a:dk1>
+      <a:lt1>
+        <a:sysClr val="window" lastClr="FFFFFF"/>
+      </a:lt1>
+      <a:dk2>
+        <a:srgbClr val="44546A"/>
+      </a:dk2>
+      <a:lt2>
+        <a:srgbClr val="E7E6E6"/>
+      </a:lt2>
+      <a:accent1>
+        <a:srgbClr val="4472C4"/>
+      </a:accent1>
+      <a:accent2>
+        <a:srgbClr val="ED7D31"/>
+      </a:accent2>
+      <a:accent3>
+        <a:srgbClr val="A5A5A5"/>
+      </a:accent3>
+      <a:accent4>
+        <a:srgbClr val="FFC000"/>
+      </a:accent4>
+      <a:accent5>
+        <a:srgbClr val="5B9BD5"/>
+      </a:accent5>
+      <a:accent6>
+        <a:srgbClr val="70AD47"/>
+      </a:accent6>
+      <a:hlink>
+        <a:srgbClr val="0563C1"/>
+      </a:hlink>
+      <a:folHlink>
+        <a:srgbClr val="954F72"/>
+      </a:folHlink>
+    </a:clrScheme>
+    <a:fontScheme name="Office">
+      <a:majorFont>
+        <a:latin typeface="Calibri Light" panose="020F0302020204030204"/>
+        <a:ea typeface=""/>
+        <a:cs typeface=""/>
+        <a:font script="Jpan" typeface="游ゴシック Light"/>
+        <a:font script="Hang" typeface="맑은 고딕"/>
+        <a:font script="Hans" typeface="等线 Light"/>
+        <a:font script="Hant" typeface="新細明體"/>
+        <a:font script="Arab" typeface="Times New Roman"/>
+        <a:font script="Hebr" typeface="Times New Roman"/>
+        <a:font script="Thai" typeface="Angsana New"/>
+        <a:font script="Ethi" typeface="Nyala"/>
+        <a:font script="Beng" typeface="Vrinda"/>
+        <a:font script="Gujr" typeface="Shruti"/>
+        <a:font script="Khmr" typeface="MoolBoran"/>
+        <a:font script="Knda" typeface="Tunga"/>
+        <a:font script="Guru" typeface="Raavi"/>
+        <a:font script="Cans" typeface="Euphemia"/>
+        <a:font script="Cher" typeface="Plantagenet Cherokee"/>
+        <a:font script="Yiii" typeface="Microsoft Yi Baiti"/>
+        <a:font script="Tibt" typeface="Microsoft Himalaya"/>
+        <a:font script="Thaa" typeface="MV Boli"/>
+        <a:font script="Deva" typeface="Mangal"/>
+        <a:font script="Telu" typeface="Gautami"/>
+        <a:font script="Taml" typeface="Latha"/>
+        <a:font script="Syrc" typeface="Estrangelo Edessa"/>
+        <a:font script="Orya" typeface="Kalinga"/>
+        <a:font script="Mlym" typeface="Kartika"/>
+        <a:font script="Laoo" typeface="DokChampa"/>
+        <a:font script="Sinh" typeface="Iskoola Pota"/>
+        <a:font script="Mong" typeface="Mongolian Baiti"/>
+        <a:font script="Viet" typeface="Times New Roman"/>
+        <a:font script="Uigh" typeface="Microsoft Uighur"/>
+        <a:font script="Geor" typeface="Sylfaen"/>
+        <a:font script="Armn" typeface="Arial"/>
+        <a:font script="Bugi" typeface="Leelawadee UI"/>
+        <a:font script="Bopo" typeface="Microsoft JhengHei"/>
+        <a:font script="Java" typeface="Javanese Text"/>
+        <a:font script="Lisu" typeface="Segoe UI"/>
+        <a:font script="Mymr" typeface="Myanmar Text"/>
+        <a:font script="Nkoo" typeface="Ebrima"/>
+        <a:font script="Olck" typeface="Nirmala UI"/>
+        <a:font script="Osma" typeface="Ebrima"/>
+        <a:font script="Phag" typeface="Phagspa"/>
+        <a:font script="Syrn" typeface="Estrangelo Edessa"/>
+        <a:font script="Syrj" typeface="Estrangelo Edessa"/>
+        <a:font script="Syre" typeface="Estrangelo Edessa"/>
+        <a:font script="Sora" typeface="Nirmala UI"/>
+        <a:font script="Tale" typeface="Microsoft Tai Le"/>
+        <a:font script="Talu" typeface="Microsoft New Tai Lue"/>
+        <a:font script="Tfng" typeface="Ebrima"/>
+      </a:majorFont>
+      <a:minorFont>
+        <a:latin typeface="Calibri" panose="020F0502020204030204"/>
+        <a:ea typeface=""/>
+        <a:cs typeface=""/>
+        <a:font script="Jpan" typeface="游ゴシック"/>
+        <a:font script="Hang" typeface="맑은 고딕"/>
+        <a:font script="Hans" typeface="等线"/>
+        <a:font script="Hant" typeface="新細明體"/>
+        <a:font script="Arab" typeface="Arial"/>
+        <a:font script="Hebr" typeface="Arial"/>
+        <a:font script="Thai" typeface="Cordia New"/>
+        <a:font script="Ethi" typeface="Nyala"/>
+        <a:font script="Beng" typeface="Vrinda"/>
+        <a:font script="Gujr" typeface="Shruti"/>
+        <a:font script="Khmr" typeface="DaunPenh"/>
+        <a:font script="Knda" typeface="Tunga"/>
+        <a:font script="Guru" typeface="Raavi"/>
+        <a:font script="Cans" typeface="Euphemia"/>
+        <a:font script="Cher" typeface="Plantagenet Cherokee"/>
+        <a:font script="Yiii" typeface="Microsoft Yi Baiti"/>
+        <a:font script="Tibt" typeface="Microsoft Himalaya"/>
+        <a:font script="Thaa" typeface="MV Boli"/>
+        <a:font script="Deva" typeface="Mangal"/>
+        <a:font script="Telu" typeface="Gautami"/>
+        <a:font script="Taml" typeface="Latha"/>
+        <a:font script="Syrc" typeface="Estrangelo Edessa"/>
+        <a:font script="Orya" typeface="Kalinga"/>
+        <a:font script="Mlym" typeface="Kartika"/>
+        <a:font script="Laoo" typeface="DokChampa"/>
+        <a:font script="Sinh" typeface="Iskoola Pota"/>
+        <a:font script="Mong" typeface="Mongolian Baiti"/>
+        <a:font script="Viet" typeface="Arial"/>
+        <a:font script="Uigh" typeface="Microsoft Uighur"/>
+        <a:font script="Geor" typeface="Sylfaen"/>
+        <a:font script="Armn" typeface="Arial"/>
+        <a:font script="Bugi" typeface="Leelawadee UI"/>
+        <a:font script="Bopo" typeface="Microsoft JhengHei"/>
+        <a:font script="Java" typeface="Javanese Text"/>
+        <a:font script="Lisu" typeface="Segoe UI"/>
+        <a:font script="Mymr" typeface="Myanmar Text"/>
+        <a:font script="Nkoo" typeface="Ebrima"/>
+        <a:font script="Olck" typeface="Nirmala UI"/>
+        <a:font script="Osma" typeface="Ebrima"/>
+        <a:font script="Phag" typeface="Phagspa"/>
+        <a:font script="Syrn" typeface="Estrangelo Edessa"/>
+        <a:font script="Syrj" typeface="Estrangelo Edessa"/>
+        <a:font script="Syre" typeface="Estrangelo Edessa"/>
+        <a:font script="Sora" typeface="Nirmala UI"/>
+        <a:font script="Tale" typeface="Microsoft Tai Le"/>
+        <a:font script="Talu" typeface="Microsoft New Tai Lue"/>
+        <a:font script="Tfng" typeface="Ebrima"/>
+      </a:minorFont>
+    </a:fontScheme>
+    <a:fmtScheme name="Office">
+      <a:fillStyleLst>
+        <a:solidFill>
+          <a:schemeClr val="phClr"/>
+        </a:solidFill>
+        <a:gradFill rotWithShape="1">
+          <a:gsLst>
+            <a:gs pos="0">
+              <a:schemeClr val="phClr">
+                <a:lumMod val="110000"/>
+                <a:satMod val="105000"/>
+                <a:tint val="67000"/>
+              </a:schemeClr>
+            </a:gs>
+            <a:gs pos="50000">
+              <a:schemeClr val="phClr">
+                <a:lumMod val="105000"/>
+                <a:satMod val="103000"/>
+                <a:tint val="73000"/>
+              </a:schemeClr>
+            </a:gs>
+            <a:gs pos="100000">
+              <a:schemeClr val="phClr">
+                <a:lumMod val="105000"/>
+                <a:satMod val="109000"/>
+                <a:tint val="81000"/>
+              </a:schemeClr>
+            </a:gs>
+          </a:gsLst>
+          <a:lin ang="5400000" scaled="0"/>
+        </a:gradFill>
+        <a:gradFill rotWithShape="1">
+          <a:gsLst>
+            <a:gs pos="0">
+              <a:schemeClr val="phClr">
+                <a:satMod val="103000"/>
+                <a:lumMod val="102000"/>
+                <a:tint val="94000"/>
+              </a:schemeClr>
+            </a:gs>
+            <a:gs pos="50000">
+              <a:schemeClr val="phClr">
+                <a:satMod val="110000"/>
+                <a:lumMod val="100000"/>
+                <a:shade val="100000"/>
+              </a:schemeClr>
+            </a:gs>
+            <a:gs pos="100000">
+              <a:schemeClr val="phClr">
+                <a:lumMod val="99000"/>
+                <a:satMod val="120000"/>
+                <a:shade val="78000"/>
+              </a:schemeClr>
+            </a:gs>
+          </a:gsLst>
+          <a:lin ang="5400000" scaled="0"/>
+        </a:gradFill>
+      </a:fillStyleLst>
+      <a:lnStyleLst>
+        <a:ln w="6350" cap="flat" cmpd="sng" algn="ctr">
+          <a:solidFill>
+            <a:schemeClr val="phClr"/>
+          </a:solidFill>
+          <a:prstDash val="solid"/>
+          <a:miter lim="800000"/>
+        </a:ln>
+        <a:ln w="12700" cap="flat" cmpd="sng" algn="ctr">
+          <a:solidFill>
+            <a:schemeClr val="phClr"/>
+          </a:solidFill>
+          <a:prstDash val="solid"/>
+          <a:miter lim="800000"/>
+        </a:ln>
+        <a:ln w="19050" cap="flat" cmpd="sng" algn="ctr">
+          <a:solidFill>
+            <a:schemeClr val="phClr"/>
+          </a:solidFill>
+          <a:prstDash val="solid"/>
+          <a:miter lim="800000"/>
+        </a:ln>
+      </a:lnStyleLst>
+      <a:effectStyleLst>
+        <a:effectStyle>
+          <a:effectLst/>
+        </a:effectStyle>
+        <a:effectStyle>
+          <a:effectLst/>
+        </a:effectStyle>
+        <a:effectStyle>
+          <a:effectLst>
+            <a:outerShdw blurRad="57150" dist="19050" dir="5400000" algn="ctr" rotWithShape="0">
+              <a:srgbClr val="000000">
+                <a:alpha val="63000"/>
+              </a:srgbClr>
+            </a:outerShdw>
+          </a:effectLst>
+        </a:effectStyle>
+      </a:effectStyleLst>
+      <a:bgFillStyleLst>
+        <a:solidFill>
+          <a:schemeClr val="phClr"/>
+        </a:solidFill>
+        <a:solidFill>
+          <a:schemeClr val="phClr">
+            <a:tint val="95000"/>
+            <a:satMod val="170000"/>
+          </a:schemeClr>
+        </a:solidFill>
+        <a:gradFill rotWithShape="1">
+          <a:gsLst>
+            <a:gs pos="0">
+              <a:schemeClr val="phClr">
+                <a:tint val="93000"/>
+                <a:satMod val="150000"/>
+                <a:shade val="98000"/>
+                <a:lumMod val="102000"/>
+              </a:schemeClr>
+            </a:gs>
+            <a:gs pos="50000">
+              <a:schemeClr val="phClr">
+                <a:tint val="98000"/>
+                <a:satMod val="130000"/>
+                <a:shade val="90000"/>
+                <a:lumMod val="103000"/>
+              </a:schemeClr>
+            </a:gs>
+            <a:gs pos="100000">
+              <a:schemeClr val="phClr">
+                <a:shade val="63000"/>
+                <a:satMod val="120000"/>
+              </a:schemeClr>
+            </a:gs>
+          </a:gsLst>
+          <a:lin ang="5400000" scaled="0"/>
+        </a:gradFill>
+      </a:bgFillStyleLst>
+    </a:fmtScheme>
+  </a:themeElements>
+  <a:objectDefaults/>
+  <a:extraClrSchemeLst/>
+  <a:extLst>
+    <a:ext uri="{05A4C25C-085E-4340-85A3-A5531E510DB2}">
+      <thm15:themeFamily xmlns:thm15="http://schemas.microsoft.com/office/thememl/2012/main" name="Office Theme" id="{62F939B6-93AF-4DB8-9C6B-D6C7DFDC589F}" vid="{4A3C46E8-61CC-4603-A589-7422A47A8E4A}"/>
+    </a:ext>
+  </a:extLst>
+</a:theme>
 </file>
</xml_diff>